<commit_message>
updated presentation and README
</commit_message>
<xml_diff>
--- a/presentation.pptx
+++ b/presentation.pptx
@@ -5,7 +5,7 @@
     <p:sldMasterId id="2147483648" r:id="rId1"/>
   </p:sldMasterIdLst>
   <p:notesMasterIdLst>
-    <p:notesMasterId r:id="rId31"/>
+    <p:notesMasterId r:id="rId30"/>
   </p:notesMasterIdLst>
   <p:sldIdLst>
     <p:sldId id="256" r:id="rId2"/>
@@ -21,22 +21,21 @@
     <p:sldId id="264" r:id="rId12"/>
     <p:sldId id="265" r:id="rId13"/>
     <p:sldId id="292" r:id="rId14"/>
-    <p:sldId id="266" r:id="rId15"/>
-    <p:sldId id="267" r:id="rId16"/>
-    <p:sldId id="259" r:id="rId17"/>
-    <p:sldId id="268" r:id="rId18"/>
-    <p:sldId id="293" r:id="rId19"/>
-    <p:sldId id="294" r:id="rId20"/>
-    <p:sldId id="271" r:id="rId21"/>
-    <p:sldId id="296" r:id="rId22"/>
-    <p:sldId id="272" r:id="rId23"/>
-    <p:sldId id="273" r:id="rId24"/>
-    <p:sldId id="295" r:id="rId25"/>
-    <p:sldId id="280" r:id="rId26"/>
-    <p:sldId id="281" r:id="rId27"/>
-    <p:sldId id="284" r:id="rId28"/>
-    <p:sldId id="282" r:id="rId29"/>
-    <p:sldId id="283" r:id="rId30"/>
+    <p:sldId id="267" r:id="rId15"/>
+    <p:sldId id="259" r:id="rId16"/>
+    <p:sldId id="268" r:id="rId17"/>
+    <p:sldId id="293" r:id="rId18"/>
+    <p:sldId id="294" r:id="rId19"/>
+    <p:sldId id="271" r:id="rId20"/>
+    <p:sldId id="296" r:id="rId21"/>
+    <p:sldId id="272" r:id="rId22"/>
+    <p:sldId id="273" r:id="rId23"/>
+    <p:sldId id="295" r:id="rId24"/>
+    <p:sldId id="280" r:id="rId25"/>
+    <p:sldId id="281" r:id="rId26"/>
+    <p:sldId id="284" r:id="rId27"/>
+    <p:sldId id="282" r:id="rId28"/>
+    <p:sldId id="283" r:id="rId29"/>
   </p:sldIdLst>
   <p:sldSz cx="12192000" cy="6858000"/>
   <p:notesSz cx="6858000" cy="9144000"/>
@@ -225,7 +224,7 @@
           <a:p>
             <a:fld id="{CBF5C662-2863-7149-ABCA-B2BE13B6142F}" type="datetimeFigureOut">
               <a:rPr lang="en-US" smtClean="0"/>
-              <a:t>3/8/25</a:t>
+              <a:t>3/1/26</a:t>
             </a:fld>
             <a:endParaRPr lang="en-US"/>
           </a:p>
@@ -558,7 +557,7 @@
           <a:p>
             <a:fld id="{07FAB8C5-B5A0-6142-A705-E0D16215C796}" type="slidenum">
               <a:rPr lang="en-US" smtClean="0"/>
-              <a:t>16</a:t>
+              <a:t>15</a:t>
             </a:fld>
             <a:endParaRPr lang="en-US"/>
           </a:p>
@@ -666,7 +665,7 @@
           <a:p>
             <a:fld id="{07FAB8C5-B5A0-6142-A705-E0D16215C796}" type="slidenum">
               <a:rPr lang="en-US" smtClean="0"/>
-              <a:t>17</a:t>
+              <a:t>16</a:t>
             </a:fld>
             <a:endParaRPr lang="en-US"/>
           </a:p>
@@ -774,7 +773,7 @@
           <a:p>
             <a:fld id="{07FAB8C5-B5A0-6142-A705-E0D16215C796}" type="slidenum">
               <a:rPr lang="en-US" smtClean="0"/>
-              <a:t>18</a:t>
+              <a:t>17</a:t>
             </a:fld>
             <a:endParaRPr lang="en-US"/>
           </a:p>
@@ -942,7 +941,7 @@
           <a:p>
             <a:fld id="{157D20D9-AF0B-5C41-8F77-057BA70C6078}" type="datetime1">
               <a:rPr lang="de-DE" smtClean="0"/>
-              <a:t>08.03.25</a:t>
+              <a:t>01.03.26</a:t>
             </a:fld>
             <a:endParaRPr lang="en-US"/>
           </a:p>
@@ -1142,7 +1141,7 @@
           <a:p>
             <a:fld id="{8FAD6751-24BC-324E-AA1D-B49C00E27E92}" type="datetime1">
               <a:rPr lang="de-DE" smtClean="0"/>
-              <a:t>08.03.25</a:t>
+              <a:t>01.03.26</a:t>
             </a:fld>
             <a:endParaRPr lang="en-US"/>
           </a:p>
@@ -1352,7 +1351,7 @@
           <a:p>
             <a:fld id="{CC2FF483-A0C4-F549-8954-6173CAB5179B}" type="datetime1">
               <a:rPr lang="de-DE" smtClean="0"/>
-              <a:t>08.03.25</a:t>
+              <a:t>01.03.26</a:t>
             </a:fld>
             <a:endParaRPr lang="en-US"/>
           </a:p>
@@ -1552,7 +1551,7 @@
           <a:p>
             <a:fld id="{80CF03B7-88CB-234C-9BEB-EF68218ADE02}" type="datetime1">
               <a:rPr lang="de-DE" smtClean="0"/>
-              <a:t>08.03.25</a:t>
+              <a:t>01.03.26</a:t>
             </a:fld>
             <a:endParaRPr lang="en-US"/>
           </a:p>
@@ -1828,7 +1827,7 @@
           <a:p>
             <a:fld id="{D4E10A60-7274-D949-916A-67ED1FB1DA3A}" type="datetime1">
               <a:rPr lang="de-DE" smtClean="0"/>
-              <a:t>08.03.25</a:t>
+              <a:t>01.03.26</a:t>
             </a:fld>
             <a:endParaRPr lang="en-US"/>
           </a:p>
@@ -2096,7 +2095,7 @@
           <a:p>
             <a:fld id="{CD73BD11-2867-2B43-AB6C-D949C19D7A1F}" type="datetime1">
               <a:rPr lang="de-DE" smtClean="0"/>
-              <a:t>08.03.25</a:t>
+              <a:t>01.03.26</a:t>
             </a:fld>
             <a:endParaRPr lang="en-US"/>
           </a:p>
@@ -2511,7 +2510,7 @@
           <a:p>
             <a:fld id="{432E4588-9480-C141-8D27-2C26CE2F2111}" type="datetime1">
               <a:rPr lang="de-DE" smtClean="0"/>
-              <a:t>08.03.25</a:t>
+              <a:t>01.03.26</a:t>
             </a:fld>
             <a:endParaRPr lang="en-US"/>
           </a:p>
@@ -2653,7 +2652,7 @@
           <a:p>
             <a:fld id="{B11FF33C-61C5-904B-A4B2-19A53024067D}" type="datetime1">
               <a:rPr lang="de-DE" smtClean="0"/>
-              <a:t>08.03.25</a:t>
+              <a:t>01.03.26</a:t>
             </a:fld>
             <a:endParaRPr lang="en-US"/>
           </a:p>
@@ -2766,7 +2765,7 @@
           <a:p>
             <a:fld id="{DF43E339-03A7-3744-B06A-12B278E368DC}" type="datetime1">
               <a:rPr lang="de-DE" smtClean="0"/>
-              <a:t>08.03.25</a:t>
+              <a:t>01.03.26</a:t>
             </a:fld>
             <a:endParaRPr lang="en-US"/>
           </a:p>
@@ -3079,7 +3078,7 @@
           <a:p>
             <a:fld id="{13BC1DA0-6012-244F-8E1E-303C0F5848CB}" type="datetime1">
               <a:rPr lang="de-DE" smtClean="0"/>
-              <a:t>08.03.25</a:t>
+              <a:t>01.03.26</a:t>
             </a:fld>
             <a:endParaRPr lang="en-US"/>
           </a:p>
@@ -3368,7 +3367,7 @@
           <a:p>
             <a:fld id="{0977AB37-F0AE-524F-832B-1EE930F79C35}" type="datetime1">
               <a:rPr lang="de-DE" smtClean="0"/>
-              <a:t>08.03.25</a:t>
+              <a:t>01.03.26</a:t>
             </a:fld>
             <a:endParaRPr lang="en-US"/>
           </a:p>
@@ -3611,7 +3610,7 @@
           <a:p>
             <a:fld id="{D8D0F54C-AF83-4D4B-AD30-5C009527964C}" type="datetime1">
               <a:rPr lang="de-DE" smtClean="0"/>
-              <a:t>08.03.25</a:t>
+              <a:t>01.03.26</a:t>
             </a:fld>
             <a:endParaRPr lang="en-US"/>
           </a:p>
@@ -4180,7 +4179,7 @@
           <a:p>
             <a:fld id="{37EE7759-0378-9945-B087-9DFA01C48CF4}" type="datetime1">
               <a:rPr lang="en-GB" noProof="1" smtClean="0"/>
-              <a:t>08/03/2025</a:t>
+              <a:t>01/03/2026</a:t>
             </a:fld>
             <a:endParaRPr lang="en-GB" noProof="1"/>
           </a:p>
@@ -5091,7 +5090,7 @@
           <a:p>
             <a:fld id="{8B25376C-0A92-6642-81FE-3BA6462A5B99}" type="datetime1">
               <a:rPr lang="en-GB" noProof="1" smtClean="0"/>
-              <a:t>08/03/2025</a:t>
+              <a:t>01/03/2026</a:t>
             </a:fld>
             <a:endParaRPr lang="en-GB" noProof="1"/>
           </a:p>
@@ -5941,7 +5940,7 @@
           <a:p>
             <a:fld id="{C7424B4B-6A38-C04F-ACE8-BEFD964B45FF}" type="datetime1">
               <a:rPr lang="en-GB" noProof="1" smtClean="0"/>
-              <a:t>08/03/2025</a:t>
+              <a:t>01/03/2026</a:t>
             </a:fld>
             <a:endParaRPr lang="en-GB" noProof="1"/>
           </a:p>
@@ -6212,7 +6211,7 @@
           <a:p>
             <a:fld id="{80CF03B7-88CB-234C-9BEB-EF68218ADE02}" type="datetime1">
               <a:rPr lang="en-GB" noProof="1" smtClean="0"/>
-              <a:t>08/03/2025</a:t>
+              <a:t>01/03/2026</a:t>
             </a:fld>
             <a:endParaRPr lang="en-GB" noProof="1"/>
           </a:p>
@@ -6569,256 +6568,6 @@
   <p:cSld>
     <p:spTree>
       <p:nvGrpSpPr>
-        <p:cNvPr id="1" name="">
-          <a:extLst>
-            <a:ext uri="{FF2B5EF4-FFF2-40B4-BE49-F238E27FC236}">
-              <a16:creationId xmlns:a16="http://schemas.microsoft.com/office/drawing/2014/main" id="{AC098539-3B75-B778-2D2B-0BB083F10C38}"/>
-            </a:ext>
-          </a:extLst>
-        </p:cNvPr>
-        <p:cNvGrpSpPr/>
-        <p:nvPr/>
-      </p:nvGrpSpPr>
-      <p:grpSpPr>
-        <a:xfrm>
-          <a:off x="0" y="0"/>
-          <a:ext cx="0" cy="0"/>
-          <a:chOff x="0" y="0"/>
-          <a:chExt cx="0" cy="0"/>
-        </a:xfrm>
-      </p:grpSpPr>
-      <p:sp>
-        <p:nvSpPr>
-          <p:cNvPr id="4" name="Title 3">
-            <a:extLst>
-              <a:ext uri="{FF2B5EF4-FFF2-40B4-BE49-F238E27FC236}">
-                <a16:creationId xmlns:a16="http://schemas.microsoft.com/office/drawing/2014/main" id="{05461B6C-3793-02CD-BEEE-CCE3A1B7F65E}"/>
-              </a:ext>
-            </a:extLst>
-          </p:cNvPr>
-          <p:cNvSpPr>
-            <a:spLocks noGrp="1"/>
-          </p:cNvSpPr>
-          <p:nvPr>
-            <p:ph type="title"/>
-          </p:nvPr>
-        </p:nvSpPr>
-        <p:spPr/>
-        <p:txBody>
-          <a:bodyPr/>
-          <a:lstStyle/>
-          <a:p>
-            <a:r>
-              <a:rPr lang="en-GB" noProof="1"/>
-              <a:t>MuData</a:t>
-            </a:r>
-          </a:p>
-        </p:txBody>
-      </p:sp>
-      <p:sp>
-        <p:nvSpPr>
-          <p:cNvPr id="2" name="Date Placeholder 1">
-            <a:extLst>
-              <a:ext uri="{FF2B5EF4-FFF2-40B4-BE49-F238E27FC236}">
-                <a16:creationId xmlns:a16="http://schemas.microsoft.com/office/drawing/2014/main" id="{59C5CA00-F469-6D6A-7C7D-D6BE356040C3}"/>
-              </a:ext>
-            </a:extLst>
-          </p:cNvPr>
-          <p:cNvSpPr>
-            <a:spLocks noGrp="1"/>
-          </p:cNvSpPr>
-          <p:nvPr>
-            <p:ph type="dt" sz="half" idx="10"/>
-          </p:nvPr>
-        </p:nvSpPr>
-        <p:spPr/>
-        <p:txBody>
-          <a:bodyPr/>
-          <a:lstStyle/>
-          <a:p>
-            <a:fld id="{43C20C05-7246-E34C-B32A-4E733F6E8AD3}" type="datetime1">
-              <a:rPr lang="en-GB" noProof="1" smtClean="0"/>
-              <a:t>08/03/2025</a:t>
-            </a:fld>
-            <a:endParaRPr lang="en-GB" noProof="1"/>
-          </a:p>
-        </p:txBody>
-      </p:sp>
-      <p:sp>
-        <p:nvSpPr>
-          <p:cNvPr id="3" name="Slide Number Placeholder 2">
-            <a:extLst>
-              <a:ext uri="{FF2B5EF4-FFF2-40B4-BE49-F238E27FC236}">
-                <a16:creationId xmlns:a16="http://schemas.microsoft.com/office/drawing/2014/main" id="{D01C7D1C-00E4-BEAD-4168-E3EDA80FB988}"/>
-              </a:ext>
-            </a:extLst>
-          </p:cNvPr>
-          <p:cNvSpPr>
-            <a:spLocks noGrp="1"/>
-          </p:cNvSpPr>
-          <p:nvPr>
-            <p:ph type="sldNum" sz="quarter" idx="12"/>
-          </p:nvPr>
-        </p:nvSpPr>
-        <p:spPr/>
-        <p:txBody>
-          <a:bodyPr/>
-          <a:lstStyle/>
-          <a:p>
-            <a:fld id="{8290730A-91D1-7245-A43C-45E268028A7B}" type="slidenum">
-              <a:rPr lang="en-GB" noProof="1" smtClean="0"/>
-              <a:t>13</a:t>
-            </a:fld>
-            <a:endParaRPr lang="en-GB" noProof="1"/>
-          </a:p>
-        </p:txBody>
-      </p:sp>
-      <p:pic>
-        <p:nvPicPr>
-          <p:cNvPr id="2050" name="Picture 2" descr="MUON: multimodal omics analysis framework | Genome Biology | Full Text">
-            <a:extLst>
-              <a:ext uri="{FF2B5EF4-FFF2-40B4-BE49-F238E27FC236}">
-                <a16:creationId xmlns:a16="http://schemas.microsoft.com/office/drawing/2014/main" id="{D0F7C0DB-1004-7A37-AB8C-F990F48E36B8}"/>
-              </a:ext>
-            </a:extLst>
-          </p:cNvPr>
-          <p:cNvPicPr>
-            <a:picLocks noChangeAspect="1" noChangeArrowheads="1"/>
-          </p:cNvPicPr>
-          <p:nvPr/>
-        </p:nvPicPr>
-        <p:blipFill>
-          <a:blip r:embed="rId2">
-            <a:extLst>
-              <a:ext uri="{28A0092B-C50C-407E-A947-70E740481C1C}">
-                <a14:useLocalDpi xmlns:a14="http://schemas.microsoft.com/office/drawing/2010/main" val="0"/>
-              </a:ext>
-            </a:extLst>
-          </a:blip>
-          <a:srcRect/>
-          <a:stretch>
-            <a:fillRect/>
-          </a:stretch>
-        </p:blipFill>
-        <p:spPr bwMode="auto">
-          <a:xfrm>
-            <a:off x="838200" y="2132013"/>
-            <a:ext cx="10515601" cy="2865775"/>
-          </a:xfrm>
-          <a:prstGeom prst="rect">
-            <a:avLst/>
-          </a:prstGeom>
-          <a:noFill/>
-          <a:extLst>
-            <a:ext uri="{909E8E84-426E-40DD-AFC4-6F175D3DCCD1}">
-              <a14:hiddenFill xmlns:a14="http://schemas.microsoft.com/office/drawing/2010/main">
-                <a:solidFill>
-                  <a:srgbClr val="FFFFFF"/>
-                </a:solidFill>
-              </a14:hiddenFill>
-            </a:ext>
-          </a:extLst>
-        </p:spPr>
-      </p:pic>
-      <p:sp>
-        <p:nvSpPr>
-          <p:cNvPr id="7" name="TextBox 6">
-            <a:extLst>
-              <a:ext uri="{FF2B5EF4-FFF2-40B4-BE49-F238E27FC236}">
-                <a16:creationId xmlns:a16="http://schemas.microsoft.com/office/drawing/2014/main" id="{D657A254-2E75-B857-1EF2-3D73BEDF126C}"/>
-              </a:ext>
-            </a:extLst>
-          </p:cNvPr>
-          <p:cNvSpPr txBox="1"/>
-          <p:nvPr/>
-        </p:nvSpPr>
-        <p:spPr>
-          <a:xfrm>
-            <a:off x="3047999" y="6415801"/>
-            <a:ext cx="8305801" cy="246221"/>
-          </a:xfrm>
-          <a:prstGeom prst="rect">
-            <a:avLst/>
-          </a:prstGeom>
-          <a:noFill/>
-        </p:spPr>
-        <p:txBody>
-          <a:bodyPr wrap="square">
-            <a:spAutoFit/>
-          </a:bodyPr>
-          <a:lstStyle/>
-          <a:p>
-            <a:r>
-              <a:rPr lang="en-GB" sz="1000" noProof="1"/>
-              <a:t>Bredikhin, Danila, Ilia Kats, and Oliver Stegle. "MUON: multimodal omics analysis framework." </a:t>
-            </a:r>
-            <a:r>
-              <a:rPr lang="en-GB" sz="1000" i="1" noProof="1"/>
-              <a:t>Genome biology</a:t>
-            </a:r>
-            <a:r>
-              <a:rPr lang="en-GB" sz="1000" noProof="1"/>
-              <a:t> 23.1 (2022): 42.</a:t>
-            </a:r>
-          </a:p>
-        </p:txBody>
-      </p:sp>
-      <p:sp>
-        <p:nvSpPr>
-          <p:cNvPr id="9" name="TextBox 8">
-            <a:extLst>
-              <a:ext uri="{FF2B5EF4-FFF2-40B4-BE49-F238E27FC236}">
-                <a16:creationId xmlns:a16="http://schemas.microsoft.com/office/drawing/2014/main" id="{87D5627A-9EB2-A207-BF3C-8C84F7D81F22}"/>
-              </a:ext>
-            </a:extLst>
-          </p:cNvPr>
-          <p:cNvSpPr txBox="1"/>
-          <p:nvPr/>
-        </p:nvSpPr>
-        <p:spPr>
-          <a:xfrm>
-            <a:off x="4606787" y="5439113"/>
-            <a:ext cx="2978426" cy="369332"/>
-          </a:xfrm>
-          <a:prstGeom prst="rect">
-            <a:avLst/>
-          </a:prstGeom>
-          <a:noFill/>
-        </p:spPr>
-        <p:txBody>
-          <a:bodyPr wrap="square">
-            <a:spAutoFit/>
-          </a:bodyPr>
-          <a:lstStyle/>
-          <a:p>
-            <a:r>
-              <a:rPr lang="en-GB" noProof="1">
-                <a:hlinkClick r:id="rId3"/>
-              </a:rPr>
-              <a:t>https://muon.readthedocs.io</a:t>
-            </a:r>
-            <a:endParaRPr lang="en-GB" noProof="1"/>
-          </a:p>
-        </p:txBody>
-      </p:sp>
-    </p:spTree>
-    <p:extLst>
-      <p:ext uri="{BB962C8B-B14F-4D97-AF65-F5344CB8AC3E}">
-        <p14:creationId xmlns:p14="http://schemas.microsoft.com/office/powerpoint/2010/main" val="418877129"/>
-      </p:ext>
-    </p:extLst>
-  </p:cSld>
-  <p:clrMapOvr>
-    <a:masterClrMapping/>
-  </p:clrMapOvr>
-</p:sld>
-</file>
-
-<file path=ppt/slides/slide15.xml><?xml version="1.0" encoding="utf-8"?>
-<p:sld xmlns:a="http://schemas.openxmlformats.org/drawingml/2006/main" xmlns:r="http://schemas.openxmlformats.org/officeDocument/2006/relationships" xmlns:p="http://schemas.openxmlformats.org/presentationml/2006/main">
-  <p:cSld>
-    <p:spTree>
-      <p:nvGrpSpPr>
         <p:cNvPr id="1" name=""/>
         <p:cNvGrpSpPr/>
         <p:nvPr/>
@@ -6882,7 +6631,7 @@
           <a:p>
             <a:fld id="{1DA4F716-1CA7-0048-9CC4-1DFDC631832C}" type="datetime1">
               <a:rPr lang="en-GB" noProof="1" smtClean="0"/>
-              <a:t>08/03/2025</a:t>
+              <a:t>01/03/2026</a:t>
             </a:fld>
             <a:endParaRPr lang="en-GB" noProof="1"/>
           </a:p>
@@ -6911,7 +6660,7 @@
           <a:p>
             <a:fld id="{8290730A-91D1-7245-A43C-45E268028A7B}" type="slidenum">
               <a:rPr lang="en-GB" noProof="1" smtClean="0"/>
-              <a:t>14</a:t>
+              <a:t>13</a:t>
             </a:fld>
             <a:endParaRPr lang="en-GB" noProof="1"/>
           </a:p>
@@ -7993,7 +7742,7 @@
 </p:sld>
 </file>
 
-<file path=ppt/slides/slide16.xml><?xml version="1.0" encoding="utf-8"?>
+<file path=ppt/slides/slide15.xml><?xml version="1.0" encoding="utf-8"?>
 <p:sld xmlns:a="http://schemas.openxmlformats.org/drawingml/2006/main" xmlns:r="http://schemas.openxmlformats.org/officeDocument/2006/relationships" xmlns:p="http://schemas.openxmlformats.org/presentationml/2006/main">
   <p:cSld>
     <p:spTree>
@@ -8095,7 +7844,7 @@
           <a:p>
             <a:fld id="{1FFEEF62-8B8C-6C4F-B015-9468474F1B68}" type="datetime1">
               <a:rPr lang="en-GB" noProof="1" smtClean="0"/>
-              <a:t>08/03/2025</a:t>
+              <a:t>01/03/2026</a:t>
             </a:fld>
             <a:endParaRPr lang="en-GB" noProof="1"/>
           </a:p>
@@ -8124,7 +7873,7 @@
           <a:p>
             <a:fld id="{8290730A-91D1-7245-A43C-45E268028A7B}" type="slidenum">
               <a:rPr lang="en-GB" noProof="1" smtClean="0"/>
-              <a:t>15</a:t>
+              <a:t>14</a:t>
             </a:fld>
             <a:endParaRPr lang="en-GB" noProof="1"/>
           </a:p>
@@ -8143,7 +7892,7 @@
 </p:sld>
 </file>
 
-<file path=ppt/slides/slide17.xml><?xml version="1.0" encoding="utf-8"?>
+<file path=ppt/slides/slide16.xml><?xml version="1.0" encoding="utf-8"?>
 <p:sld xmlns:a="http://schemas.openxmlformats.org/drawingml/2006/main" xmlns:r="http://schemas.openxmlformats.org/officeDocument/2006/relationships" xmlns:p="http://schemas.openxmlformats.org/presentationml/2006/main">
   <p:cSld>
     <p:spTree>
@@ -8313,7 +8062,7 @@
           <a:p>
             <a:fld id="{C7C47853-C6BA-9F4D-88AE-F144534F64A4}" type="datetime1">
               <a:rPr lang="en-GB" noProof="1" smtClean="0"/>
-              <a:t>08/03/2025</a:t>
+              <a:t>01/03/2026</a:t>
             </a:fld>
             <a:endParaRPr lang="en-GB" noProof="1"/>
           </a:p>
@@ -8342,7 +8091,7 @@
           <a:p>
             <a:fld id="{8290730A-91D1-7245-A43C-45E268028A7B}" type="slidenum">
               <a:rPr lang="en-GB" noProof="1" smtClean="0"/>
-              <a:t>16</a:t>
+              <a:t>15</a:t>
             </a:fld>
             <a:endParaRPr lang="en-GB" noProof="1"/>
           </a:p>
@@ -8589,7 +8338,7 @@
 </p:sld>
 </file>
 
-<file path=ppt/slides/slide18.xml><?xml version="1.0" encoding="utf-8"?>
+<file path=ppt/slides/slide17.xml><?xml version="1.0" encoding="utf-8"?>
 <p:sld xmlns:a="http://schemas.openxmlformats.org/drawingml/2006/main" xmlns:r="http://schemas.openxmlformats.org/officeDocument/2006/relationships" xmlns:p="http://schemas.openxmlformats.org/presentationml/2006/main">
   <p:cSld>
     <p:spTree>
@@ -8663,7 +8412,7 @@
           <a:p>
             <a:fld id="{C7C47853-C6BA-9F4D-88AE-F144534F64A4}" type="datetime1">
               <a:rPr lang="en-GB" noProof="1" smtClean="0"/>
-              <a:t>08/03/2025</a:t>
+              <a:t>01/03/2026</a:t>
             </a:fld>
             <a:endParaRPr lang="en-GB" noProof="1"/>
           </a:p>
@@ -8692,7 +8441,7 @@
           <a:p>
             <a:fld id="{8290730A-91D1-7245-A43C-45E268028A7B}" type="slidenum">
               <a:rPr lang="en-GB" noProof="1" smtClean="0"/>
-              <a:t>17</a:t>
+              <a:t>16</a:t>
             </a:fld>
             <a:endParaRPr lang="en-GB" noProof="1"/>
           </a:p>
@@ -9710,7 +9459,7 @@
 </p:sld>
 </file>
 
-<file path=ppt/slides/slide19.xml><?xml version="1.0" encoding="utf-8"?>
+<file path=ppt/slides/slide18.xml><?xml version="1.0" encoding="utf-8"?>
 <p:sld xmlns:a="http://schemas.openxmlformats.org/drawingml/2006/main" xmlns:r="http://schemas.openxmlformats.org/officeDocument/2006/relationships" xmlns:p="http://schemas.openxmlformats.org/presentationml/2006/main">
   <p:cSld>
     <p:spTree>
@@ -9784,7 +9533,7 @@
           <a:p>
             <a:fld id="{C7C47853-C6BA-9F4D-88AE-F144534F64A4}" type="datetime1">
               <a:rPr lang="en-GB" noProof="1" smtClean="0"/>
-              <a:t>08/03/2025</a:t>
+              <a:t>01/03/2026</a:t>
             </a:fld>
             <a:endParaRPr lang="en-GB" noProof="1"/>
           </a:p>
@@ -9813,7 +9562,7 @@
           <a:p>
             <a:fld id="{8290730A-91D1-7245-A43C-45E268028A7B}" type="slidenum">
               <a:rPr lang="en-GB" noProof="1" smtClean="0"/>
-              <a:t>18</a:t>
+              <a:t>17</a:t>
             </a:fld>
             <a:endParaRPr lang="en-GB" noProof="1"/>
           </a:p>
@@ -10708,151 +10457,7 @@
 </p:sld>
 </file>
 
-<file path=ppt/slides/slide2.xml><?xml version="1.0" encoding="utf-8"?>
-<p:sld xmlns:a="http://schemas.openxmlformats.org/drawingml/2006/main" xmlns:r="http://schemas.openxmlformats.org/officeDocument/2006/relationships" xmlns:p="http://schemas.openxmlformats.org/presentationml/2006/main">
-  <p:cSld>
-    <p:spTree>
-      <p:nvGrpSpPr>
-        <p:cNvPr id="1" name=""/>
-        <p:cNvGrpSpPr/>
-        <p:nvPr/>
-      </p:nvGrpSpPr>
-      <p:grpSpPr>
-        <a:xfrm>
-          <a:off x="0" y="0"/>
-          <a:ext cx="0" cy="0"/>
-          <a:chOff x="0" y="0"/>
-          <a:chExt cx="0" cy="0"/>
-        </a:xfrm>
-      </p:grpSpPr>
-      <p:sp>
-        <p:nvSpPr>
-          <p:cNvPr id="2" name="Title 1">
-            <a:extLst>
-              <a:ext uri="{FF2B5EF4-FFF2-40B4-BE49-F238E27FC236}">
-                <a16:creationId xmlns:a16="http://schemas.microsoft.com/office/drawing/2014/main" id="{3BCAEEBB-B95F-F28A-F63E-0F16253078D5}"/>
-              </a:ext>
-            </a:extLst>
-          </p:cNvPr>
-          <p:cNvSpPr>
-            <a:spLocks noGrp="1"/>
-          </p:cNvSpPr>
-          <p:nvPr>
-            <p:ph type="title"/>
-          </p:nvPr>
-        </p:nvSpPr>
-        <p:spPr/>
-        <p:txBody>
-          <a:bodyPr/>
-          <a:lstStyle/>
-          <a:p>
-            <a:r>
-              <a:rPr lang="en-GB" noProof="1"/>
-              <a:t>Project Introduction</a:t>
-            </a:r>
-          </a:p>
-        </p:txBody>
-      </p:sp>
-      <p:sp>
-        <p:nvSpPr>
-          <p:cNvPr id="4" name="Text Placeholder 3">
-            <a:extLst>
-              <a:ext uri="{FF2B5EF4-FFF2-40B4-BE49-F238E27FC236}">
-                <a16:creationId xmlns:a16="http://schemas.microsoft.com/office/drawing/2014/main" id="{40EA2C46-EC85-F4A8-DDE9-F211251718FA}"/>
-              </a:ext>
-            </a:extLst>
-          </p:cNvPr>
-          <p:cNvSpPr>
-            <a:spLocks noGrp="1"/>
-          </p:cNvSpPr>
-          <p:nvPr>
-            <p:ph type="body" idx="1"/>
-          </p:nvPr>
-        </p:nvSpPr>
-        <p:spPr/>
-        <p:txBody>
-          <a:bodyPr/>
-          <a:lstStyle/>
-          <a:p>
-            <a:r>
-              <a:rPr lang="en-GB" noProof="1"/>
-              <a:t>What to expect</a:t>
-            </a:r>
-          </a:p>
-        </p:txBody>
-      </p:sp>
-      <p:sp>
-        <p:nvSpPr>
-          <p:cNvPr id="5" name="Date Placeholder 4">
-            <a:extLst>
-              <a:ext uri="{FF2B5EF4-FFF2-40B4-BE49-F238E27FC236}">
-                <a16:creationId xmlns:a16="http://schemas.microsoft.com/office/drawing/2014/main" id="{5EA4D092-3726-2947-5C57-0D51EE1382FA}"/>
-              </a:ext>
-            </a:extLst>
-          </p:cNvPr>
-          <p:cNvSpPr>
-            <a:spLocks noGrp="1"/>
-          </p:cNvSpPr>
-          <p:nvPr>
-            <p:ph type="dt" sz="half" idx="10"/>
-          </p:nvPr>
-        </p:nvSpPr>
-        <p:spPr/>
-        <p:txBody>
-          <a:bodyPr/>
-          <a:lstStyle/>
-          <a:p>
-            <a:fld id="{EF5388C8-6145-1D43-A4F9-77635DD7FBD7}" type="datetime1">
-              <a:rPr lang="en-GB" noProof="1" smtClean="0"/>
-              <a:t>08/03/2025</a:t>
-            </a:fld>
-            <a:endParaRPr lang="en-GB" noProof="1"/>
-          </a:p>
-        </p:txBody>
-      </p:sp>
-      <p:sp>
-        <p:nvSpPr>
-          <p:cNvPr id="6" name="Slide Number Placeholder 5">
-            <a:extLst>
-              <a:ext uri="{FF2B5EF4-FFF2-40B4-BE49-F238E27FC236}">
-                <a16:creationId xmlns:a16="http://schemas.microsoft.com/office/drawing/2014/main" id="{DCABB19E-AFAA-692A-EF9F-32EC0CB1F032}"/>
-              </a:ext>
-            </a:extLst>
-          </p:cNvPr>
-          <p:cNvSpPr>
-            <a:spLocks noGrp="1"/>
-          </p:cNvSpPr>
-          <p:nvPr>
-            <p:ph type="sldNum" sz="quarter" idx="12"/>
-          </p:nvPr>
-        </p:nvSpPr>
-        <p:spPr/>
-        <p:txBody>
-          <a:bodyPr/>
-          <a:lstStyle/>
-          <a:p>
-            <a:fld id="{8290730A-91D1-7245-A43C-45E268028A7B}" type="slidenum">
-              <a:rPr lang="en-GB" noProof="1" smtClean="0"/>
-              <a:t>1</a:t>
-            </a:fld>
-            <a:endParaRPr lang="en-GB" noProof="1"/>
-          </a:p>
-        </p:txBody>
-      </p:sp>
-    </p:spTree>
-    <p:extLst>
-      <p:ext uri="{BB962C8B-B14F-4D97-AF65-F5344CB8AC3E}">
-        <p14:creationId xmlns:p14="http://schemas.microsoft.com/office/powerpoint/2010/main" val="669306779"/>
-      </p:ext>
-    </p:extLst>
-  </p:cSld>
-  <p:clrMapOvr>
-    <a:masterClrMapping/>
-  </p:clrMapOvr>
-</p:sld>
-</file>
-
-<file path=ppt/slides/slide20.xml><?xml version="1.0" encoding="utf-8"?>
+<file path=ppt/slides/slide19.xml><?xml version="1.0" encoding="utf-8"?>
 <p:sld xmlns:a="http://schemas.openxmlformats.org/drawingml/2006/main" xmlns:r="http://schemas.openxmlformats.org/officeDocument/2006/relationships" xmlns:p="http://schemas.openxmlformats.org/presentationml/2006/main">
   <p:cSld>
     <p:spTree>
@@ -10926,7 +10531,7 @@
           <a:p>
             <a:fld id="{945FB080-5B11-9C42-8C2B-BE8BE4F681D4}" type="datetime1">
               <a:rPr lang="en-GB" noProof="1" smtClean="0"/>
-              <a:t>08/03/2025</a:t>
+              <a:t>01/03/2026</a:t>
             </a:fld>
             <a:endParaRPr lang="en-GB" noProof="1"/>
           </a:p>
@@ -10955,7 +10560,7 @@
           <a:p>
             <a:fld id="{8290730A-91D1-7245-A43C-45E268028A7B}" type="slidenum">
               <a:rPr lang="en-GB" noProof="1" smtClean="0"/>
-              <a:t>19</a:t>
+              <a:t>18</a:t>
             </a:fld>
             <a:endParaRPr lang="en-GB" noProof="1"/>
           </a:p>
@@ -14696,7 +14301,151 @@
 </p:sld>
 </file>
 
-<file path=ppt/slides/slide21.xml><?xml version="1.0" encoding="utf-8"?>
+<file path=ppt/slides/slide2.xml><?xml version="1.0" encoding="utf-8"?>
+<p:sld xmlns:a="http://schemas.openxmlformats.org/drawingml/2006/main" xmlns:r="http://schemas.openxmlformats.org/officeDocument/2006/relationships" xmlns:p="http://schemas.openxmlformats.org/presentationml/2006/main">
+  <p:cSld>
+    <p:spTree>
+      <p:nvGrpSpPr>
+        <p:cNvPr id="1" name=""/>
+        <p:cNvGrpSpPr/>
+        <p:nvPr/>
+      </p:nvGrpSpPr>
+      <p:grpSpPr>
+        <a:xfrm>
+          <a:off x="0" y="0"/>
+          <a:ext cx="0" cy="0"/>
+          <a:chOff x="0" y="0"/>
+          <a:chExt cx="0" cy="0"/>
+        </a:xfrm>
+      </p:grpSpPr>
+      <p:sp>
+        <p:nvSpPr>
+          <p:cNvPr id="2" name="Title 1">
+            <a:extLst>
+              <a:ext uri="{FF2B5EF4-FFF2-40B4-BE49-F238E27FC236}">
+                <a16:creationId xmlns:a16="http://schemas.microsoft.com/office/drawing/2014/main" id="{3BCAEEBB-B95F-F28A-F63E-0F16253078D5}"/>
+              </a:ext>
+            </a:extLst>
+          </p:cNvPr>
+          <p:cNvSpPr>
+            <a:spLocks noGrp="1"/>
+          </p:cNvSpPr>
+          <p:nvPr>
+            <p:ph type="title"/>
+          </p:nvPr>
+        </p:nvSpPr>
+        <p:spPr/>
+        <p:txBody>
+          <a:bodyPr/>
+          <a:lstStyle/>
+          <a:p>
+            <a:r>
+              <a:rPr lang="en-GB" noProof="1"/>
+              <a:t>Project Introduction</a:t>
+            </a:r>
+          </a:p>
+        </p:txBody>
+      </p:sp>
+      <p:sp>
+        <p:nvSpPr>
+          <p:cNvPr id="4" name="Text Placeholder 3">
+            <a:extLst>
+              <a:ext uri="{FF2B5EF4-FFF2-40B4-BE49-F238E27FC236}">
+                <a16:creationId xmlns:a16="http://schemas.microsoft.com/office/drawing/2014/main" id="{40EA2C46-EC85-F4A8-DDE9-F211251718FA}"/>
+              </a:ext>
+            </a:extLst>
+          </p:cNvPr>
+          <p:cNvSpPr>
+            <a:spLocks noGrp="1"/>
+          </p:cNvSpPr>
+          <p:nvPr>
+            <p:ph type="body" idx="1"/>
+          </p:nvPr>
+        </p:nvSpPr>
+        <p:spPr/>
+        <p:txBody>
+          <a:bodyPr/>
+          <a:lstStyle/>
+          <a:p>
+            <a:r>
+              <a:rPr lang="en-GB" noProof="1"/>
+              <a:t>What to expect</a:t>
+            </a:r>
+          </a:p>
+        </p:txBody>
+      </p:sp>
+      <p:sp>
+        <p:nvSpPr>
+          <p:cNvPr id="5" name="Date Placeholder 4">
+            <a:extLst>
+              <a:ext uri="{FF2B5EF4-FFF2-40B4-BE49-F238E27FC236}">
+                <a16:creationId xmlns:a16="http://schemas.microsoft.com/office/drawing/2014/main" id="{5EA4D092-3726-2947-5C57-0D51EE1382FA}"/>
+              </a:ext>
+            </a:extLst>
+          </p:cNvPr>
+          <p:cNvSpPr>
+            <a:spLocks noGrp="1"/>
+          </p:cNvSpPr>
+          <p:nvPr>
+            <p:ph type="dt" sz="half" idx="10"/>
+          </p:nvPr>
+        </p:nvSpPr>
+        <p:spPr/>
+        <p:txBody>
+          <a:bodyPr/>
+          <a:lstStyle/>
+          <a:p>
+            <a:fld id="{EF5388C8-6145-1D43-A4F9-77635DD7FBD7}" type="datetime1">
+              <a:rPr lang="en-GB" noProof="1" smtClean="0"/>
+              <a:t>01/03/2026</a:t>
+            </a:fld>
+            <a:endParaRPr lang="en-GB" noProof="1"/>
+          </a:p>
+        </p:txBody>
+      </p:sp>
+      <p:sp>
+        <p:nvSpPr>
+          <p:cNvPr id="6" name="Slide Number Placeholder 5">
+            <a:extLst>
+              <a:ext uri="{FF2B5EF4-FFF2-40B4-BE49-F238E27FC236}">
+                <a16:creationId xmlns:a16="http://schemas.microsoft.com/office/drawing/2014/main" id="{DCABB19E-AFAA-692A-EF9F-32EC0CB1F032}"/>
+              </a:ext>
+            </a:extLst>
+          </p:cNvPr>
+          <p:cNvSpPr>
+            <a:spLocks noGrp="1"/>
+          </p:cNvSpPr>
+          <p:nvPr>
+            <p:ph type="sldNum" sz="quarter" idx="12"/>
+          </p:nvPr>
+        </p:nvSpPr>
+        <p:spPr/>
+        <p:txBody>
+          <a:bodyPr/>
+          <a:lstStyle/>
+          <a:p>
+            <a:fld id="{8290730A-91D1-7245-A43C-45E268028A7B}" type="slidenum">
+              <a:rPr lang="en-GB" noProof="1" smtClean="0"/>
+              <a:t>1</a:t>
+            </a:fld>
+            <a:endParaRPr lang="en-GB" noProof="1"/>
+          </a:p>
+        </p:txBody>
+      </p:sp>
+    </p:spTree>
+    <p:extLst>
+      <p:ext uri="{BB962C8B-B14F-4D97-AF65-F5344CB8AC3E}">
+        <p14:creationId xmlns:p14="http://schemas.microsoft.com/office/powerpoint/2010/main" val="669306779"/>
+      </p:ext>
+    </p:extLst>
+  </p:cSld>
+  <p:clrMapOvr>
+    <a:masterClrMapping/>
+  </p:clrMapOvr>
+</p:sld>
+</file>
+
+<file path=ppt/slides/slide20.xml><?xml version="1.0" encoding="utf-8"?>
 <p:sld xmlns:a="http://schemas.openxmlformats.org/drawingml/2006/main" xmlns:r="http://schemas.openxmlformats.org/officeDocument/2006/relationships" xmlns:p="http://schemas.openxmlformats.org/presentationml/2006/main">
   <p:cSld>
     <p:spTree>
@@ -14770,7 +14519,7 @@
           <a:p>
             <a:fld id="{945FB080-5B11-9C42-8C2B-BE8BE4F681D4}" type="datetime1">
               <a:rPr lang="en-GB" noProof="1" smtClean="0"/>
-              <a:t>08/03/2025</a:t>
+              <a:t>01/03/2026</a:t>
             </a:fld>
             <a:endParaRPr lang="en-GB" noProof="1"/>
           </a:p>
@@ -14799,7 +14548,7 @@
           <a:p>
             <a:fld id="{8290730A-91D1-7245-A43C-45E268028A7B}" type="slidenum">
               <a:rPr lang="en-GB" noProof="1" smtClean="0"/>
-              <a:t>20</a:t>
+              <a:t>19</a:t>
             </a:fld>
             <a:endParaRPr lang="en-GB" noProof="1"/>
           </a:p>
@@ -18404,7 +18153,7 @@
 </p:sld>
 </file>
 
-<file path=ppt/slides/slide22.xml><?xml version="1.0" encoding="utf-8"?>
+<file path=ppt/slides/slide21.xml><?xml version="1.0" encoding="utf-8"?>
 <p:sld xmlns:a="http://schemas.openxmlformats.org/drawingml/2006/main" xmlns:r="http://schemas.openxmlformats.org/officeDocument/2006/relationships" xmlns:p="http://schemas.openxmlformats.org/presentationml/2006/main">
   <p:cSld>
     <p:spTree>
@@ -18570,7 +18319,7 @@
           <a:p>
             <a:fld id="{9F536774-A431-714A-93C6-B898D597FD87}" type="datetime1">
               <a:rPr lang="en-GB" noProof="1" smtClean="0"/>
-              <a:t>08/03/2025</a:t>
+              <a:t>01/03/2026</a:t>
             </a:fld>
             <a:endParaRPr lang="en-GB" noProof="1"/>
           </a:p>
@@ -18599,7 +18348,7 @@
           <a:p>
             <a:fld id="{8290730A-91D1-7245-A43C-45E268028A7B}" type="slidenum">
               <a:rPr lang="en-GB" noProof="1" smtClean="0"/>
-              <a:t>21</a:t>
+              <a:t>20</a:t>
             </a:fld>
             <a:endParaRPr lang="en-GB" noProof="1"/>
           </a:p>
@@ -20284,7 +20033,7 @@
 </p:sld>
 </file>
 
-<file path=ppt/slides/slide23.xml><?xml version="1.0" encoding="utf-8"?>
+<file path=ppt/slides/slide22.xml><?xml version="1.0" encoding="utf-8"?>
 <p:sld xmlns:a="http://schemas.openxmlformats.org/drawingml/2006/main" xmlns:r="http://schemas.openxmlformats.org/officeDocument/2006/relationships" xmlns:p="http://schemas.openxmlformats.org/presentationml/2006/main">
   <p:cSld>
     <p:spTree>
@@ -20358,7 +20107,7 @@
           <a:p>
             <a:fld id="{1A5DF876-D6AB-F548-80BF-5F7B6C93B7AC}" type="datetime1">
               <a:rPr lang="en-GB" noProof="1" smtClean="0"/>
-              <a:t>08/03/2025</a:t>
+              <a:t>01/03/2026</a:t>
             </a:fld>
             <a:endParaRPr lang="en-GB" noProof="1"/>
           </a:p>
@@ -20387,7 +20136,7 @@
           <a:p>
             <a:fld id="{8290730A-91D1-7245-A43C-45E268028A7B}" type="slidenum">
               <a:rPr lang="en-GB" noProof="1" smtClean="0"/>
-              <a:t>22</a:t>
+              <a:t>21</a:t>
             </a:fld>
             <a:endParaRPr lang="en-GB" noProof="1"/>
           </a:p>
@@ -20480,7 +20229,7 @@
 </p:sld>
 </file>
 
-<file path=ppt/slides/slide24.xml><?xml version="1.0" encoding="utf-8"?>
+<file path=ppt/slides/slide23.xml><?xml version="1.0" encoding="utf-8"?>
 <p:sld xmlns:a="http://schemas.openxmlformats.org/drawingml/2006/main" xmlns:r="http://schemas.openxmlformats.org/officeDocument/2006/relationships" xmlns:p="http://schemas.openxmlformats.org/presentationml/2006/main">
   <p:cSld>
     <p:spTree>
@@ -20554,7 +20303,7 @@
           <a:p>
             <a:fld id="{1A5DF876-D6AB-F548-80BF-5F7B6C93B7AC}" type="datetime1">
               <a:rPr lang="en-GB" noProof="1" smtClean="0"/>
-              <a:t>08/03/2025</a:t>
+              <a:t>01/03/2026</a:t>
             </a:fld>
             <a:endParaRPr lang="en-GB" noProof="1"/>
           </a:p>
@@ -20583,7 +20332,7 @@
           <a:p>
             <a:fld id="{8290730A-91D1-7245-A43C-45E268028A7B}" type="slidenum">
               <a:rPr lang="en-GB" noProof="1" smtClean="0"/>
-              <a:t>23</a:t>
+              <a:t>22</a:t>
             </a:fld>
             <a:endParaRPr lang="en-GB" noProof="1"/>
           </a:p>
@@ -20762,7 +20511,7 @@
 </p:sld>
 </file>
 
-<file path=ppt/slides/slide25.xml><?xml version="1.0" encoding="utf-8"?>
+<file path=ppt/slides/slide24.xml><?xml version="1.0" encoding="utf-8"?>
 <p:sld xmlns:a="http://schemas.openxmlformats.org/drawingml/2006/main" xmlns:r="http://schemas.openxmlformats.org/officeDocument/2006/relationships" xmlns:p="http://schemas.openxmlformats.org/presentationml/2006/main">
   <p:cSld>
     <p:spTree>
@@ -20830,7 +20579,7 @@
           <a:p>
             <a:fld id="{B12C864B-A2E3-AA4D-98B4-AEF83461A302}" type="datetime1">
               <a:rPr lang="en-GB" noProof="1" smtClean="0"/>
-              <a:t>08/03/2025</a:t>
+              <a:t>01/03/2026</a:t>
             </a:fld>
             <a:endParaRPr lang="en-GB" noProof="1"/>
           </a:p>
@@ -20859,7 +20608,7 @@
           <a:p>
             <a:fld id="{8290730A-91D1-7245-A43C-45E268028A7B}" type="slidenum">
               <a:rPr lang="en-GB" noProof="1" smtClean="0"/>
-              <a:t>24</a:t>
+              <a:t>23</a:t>
             </a:fld>
             <a:endParaRPr lang="en-GB" noProof="1"/>
           </a:p>
@@ -22099,7 +21848,7 @@
 </p:sld>
 </file>
 
-<file path=ppt/slides/slide26.xml><?xml version="1.0" encoding="utf-8"?>
+<file path=ppt/slides/slide25.xml><?xml version="1.0" encoding="utf-8"?>
 <p:sld xmlns:a="http://schemas.openxmlformats.org/drawingml/2006/main" xmlns:r="http://schemas.openxmlformats.org/officeDocument/2006/relationships" xmlns:p="http://schemas.openxmlformats.org/presentationml/2006/main">
   <p:cSld>
     <p:spTree>
@@ -22167,7 +21916,7 @@
           <a:p>
             <a:fld id="{CD411E8C-5083-5447-A32B-0C1CCBB9375A}" type="datetime1">
               <a:rPr lang="en-GB" noProof="1" smtClean="0"/>
-              <a:t>08/03/2025</a:t>
+              <a:t>01/03/2026</a:t>
             </a:fld>
             <a:endParaRPr lang="en-GB" noProof="1"/>
           </a:p>
@@ -22196,7 +21945,7 @@
           <a:p>
             <a:fld id="{8290730A-91D1-7245-A43C-45E268028A7B}" type="slidenum">
               <a:rPr lang="en-GB" noProof="1" smtClean="0"/>
-              <a:t>25</a:t>
+              <a:t>24</a:t>
             </a:fld>
             <a:endParaRPr lang="en-GB" noProof="1"/>
           </a:p>
@@ -23645,7 +23394,7 @@
 </p:sld>
 </file>
 
-<file path=ppt/slides/slide27.xml><?xml version="1.0" encoding="utf-8"?>
+<file path=ppt/slides/slide26.xml><?xml version="1.0" encoding="utf-8"?>
 <p:sld xmlns:a="http://schemas.openxmlformats.org/drawingml/2006/main" xmlns:r="http://schemas.openxmlformats.org/officeDocument/2006/relationships" xmlns:p="http://schemas.openxmlformats.org/presentationml/2006/main">
   <p:cSld>
     <p:spTree>
@@ -23719,7 +23468,7 @@
           <a:p>
             <a:fld id="{EFEBB04E-1A4D-BD4E-844E-3F1526DEA533}" type="datetime1">
               <a:rPr lang="en-GB" noProof="1" smtClean="0"/>
-              <a:t>08/03/2025</a:t>
+              <a:t>01/03/2026</a:t>
             </a:fld>
             <a:endParaRPr lang="en-GB" noProof="1"/>
           </a:p>
@@ -23748,7 +23497,7 @@
           <a:p>
             <a:fld id="{8290730A-91D1-7245-A43C-45E268028A7B}" type="slidenum">
               <a:rPr lang="en-GB" noProof="1" smtClean="0"/>
-              <a:t>26</a:t>
+              <a:t>25</a:t>
             </a:fld>
             <a:endParaRPr lang="en-GB" noProof="1"/>
           </a:p>
@@ -24032,7 +23781,7 @@
 </p:sld>
 </file>
 
-<file path=ppt/slides/slide28.xml><?xml version="1.0" encoding="utf-8"?>
+<file path=ppt/slides/slide27.xml><?xml version="1.0" encoding="utf-8"?>
 <p:sld xmlns:a="http://schemas.openxmlformats.org/drawingml/2006/main" xmlns:r="http://schemas.openxmlformats.org/officeDocument/2006/relationships" xmlns:p="http://schemas.openxmlformats.org/presentationml/2006/main">
   <p:cSld>
     <p:spTree>
@@ -24106,7 +23855,7 @@
           <a:p>
             <a:fld id="{3039EC9A-DEBF-F04C-8900-AFD10D4E4FCA}" type="datetime1">
               <a:rPr lang="en-GB" noProof="1" smtClean="0"/>
-              <a:t>08/03/2025</a:t>
+              <a:t>01/03/2026</a:t>
             </a:fld>
             <a:endParaRPr lang="en-GB" noProof="1"/>
           </a:p>
@@ -24135,7 +23884,7 @@
           <a:p>
             <a:fld id="{8290730A-91D1-7245-A43C-45E268028A7B}" type="slidenum">
               <a:rPr lang="en-GB" noProof="1" smtClean="0"/>
-              <a:t>27</a:t>
+              <a:t>26</a:t>
             </a:fld>
             <a:endParaRPr lang="en-GB" noProof="1"/>
           </a:p>
@@ -24447,7 +24196,7 @@
 </p:sld>
 </file>
 
-<file path=ppt/slides/slide29.xml><?xml version="1.0" encoding="utf-8"?>
+<file path=ppt/slides/slide28.xml><?xml version="1.0" encoding="utf-8"?>
 <p:sld xmlns:a="http://schemas.openxmlformats.org/drawingml/2006/main" xmlns:r="http://schemas.openxmlformats.org/officeDocument/2006/relationships" xmlns:p="http://schemas.openxmlformats.org/presentationml/2006/main">
   <p:cSld>
     <p:spTree>
@@ -24521,7 +24270,7 @@
           <a:p>
             <a:fld id="{A7ED8E76-BAB7-D644-A0D8-AD99AB600281}" type="datetime1">
               <a:rPr lang="en-GB" noProof="1" smtClean="0"/>
-              <a:t>08/03/2025</a:t>
+              <a:t>01/03/2026</a:t>
             </a:fld>
             <a:endParaRPr lang="en-GB" noProof="1"/>
           </a:p>
@@ -24550,7 +24299,7 @@
           <a:p>
             <a:fld id="{8290730A-91D1-7245-A43C-45E268028A7B}" type="slidenum">
               <a:rPr lang="en-GB" noProof="1" smtClean="0"/>
-              <a:t>28</a:t>
+              <a:t>27</a:t>
             </a:fld>
             <a:endParaRPr lang="en-GB" noProof="1"/>
           </a:p>
@@ -26522,7 +26271,7 @@
           <a:p>
             <a:fld id="{41F41288-0D9F-BD4B-8F1C-39810479B2DA}" type="datetime1">
               <a:rPr lang="en-GB" noProof="1" smtClean="0"/>
-              <a:t>08/03/2025</a:t>
+              <a:t>01/03/2026</a:t>
             </a:fld>
             <a:endParaRPr lang="en-GB" noProof="1"/>
           </a:p>
@@ -27922,7 +27671,7 @@
           <a:p>
             <a:fld id="{82323433-5E39-5943-B9CB-5C8341A278AD}" type="datetime1">
               <a:rPr lang="en-GB" noProof="1" smtClean="0"/>
-              <a:t>08/03/2025</a:t>
+              <a:t>01/03/2026</a:t>
             </a:fld>
             <a:endParaRPr lang="en-GB" noProof="1"/>
           </a:p>
@@ -28290,7 +28039,7 @@
           <a:p>
             <a:fld id="{7BB365F0-2983-8C4D-A342-C5614B0FE464}" type="datetime1">
               <a:rPr lang="en-GB" noProof="1" smtClean="0"/>
-              <a:t>08/03/2025</a:t>
+              <a:t>01/03/2026</a:t>
             </a:fld>
             <a:endParaRPr lang="en-GB" noProof="1"/>
           </a:p>
@@ -28698,7 +28447,7 @@
           <a:p>
             <a:fld id="{1A5DF876-D6AB-F548-80BF-5F7B6C93B7AC}" type="datetime1">
               <a:rPr lang="en-GB" noProof="1" smtClean="0"/>
-              <a:t>08/03/2025</a:t>
+              <a:t>01/03/2026</a:t>
             </a:fld>
             <a:endParaRPr lang="en-GB" noProof="1"/>
           </a:p>
@@ -29145,7 +28894,7 @@
           <a:p>
             <a:fld id="{28DE6EF9-0760-494F-8CA5-AB4794A743D6}" type="datetime1">
               <a:rPr lang="en-GB" noProof="1" smtClean="0"/>
-              <a:t>08/03/2025</a:t>
+              <a:t>01/03/2026</a:t>
             </a:fld>
             <a:endParaRPr lang="en-GB" noProof="1"/>
           </a:p>
@@ -30229,7 +29978,7 @@
           <a:p>
             <a:fld id="{28DE6EF9-0760-494F-8CA5-AB4794A743D6}" type="datetime1">
               <a:rPr lang="en-GB" noProof="1" smtClean="0"/>
-              <a:t>08/03/2025</a:t>
+              <a:t>01/03/2026</a:t>
             </a:fld>
             <a:endParaRPr lang="en-GB" noProof="1"/>
           </a:p>
@@ -30302,51 +30051,6 @@
       </p:pic>
       <p:pic>
         <p:nvPicPr>
-          <p:cNvPr id="8" name="Picture 2" descr="MUON: multimodal omics analysis framework | Genome Biology | Full Text">
-            <a:extLst>
-              <a:ext uri="{FF2B5EF4-FFF2-40B4-BE49-F238E27FC236}">
-                <a16:creationId xmlns:a16="http://schemas.microsoft.com/office/drawing/2014/main" id="{9F4877CB-8E4D-A2EB-B145-7512A5FF3E3B}"/>
-              </a:ext>
-            </a:extLst>
-          </p:cNvPr>
-          <p:cNvPicPr>
-            <a:picLocks noChangeAspect="1" noChangeArrowheads="1"/>
-          </p:cNvPicPr>
-          <p:nvPr/>
-        </p:nvPicPr>
-        <p:blipFill rotWithShape="1">
-          <a:blip r:embed="rId4">
-            <a:extLst>
-              <a:ext uri="{28A0092B-C50C-407E-A947-70E740481C1C}">
-                <a14:useLocalDpi xmlns:a14="http://schemas.microsoft.com/office/drawing/2010/main" val="0"/>
-              </a:ext>
-            </a:extLst>
-          </a:blip>
-          <a:srcRect r="72918"/>
-          <a:stretch/>
-        </p:blipFill>
-        <p:spPr bwMode="auto">
-          <a:xfrm>
-            <a:off x="8531133" y="2325687"/>
-            <a:ext cx="1225731" cy="1233453"/>
-          </a:xfrm>
-          <a:prstGeom prst="rect">
-            <a:avLst/>
-          </a:prstGeom>
-          <a:noFill/>
-          <a:extLst>
-            <a:ext uri="{909E8E84-426E-40DD-AFC4-6F175D3DCCD1}">
-              <a14:hiddenFill xmlns:a14="http://schemas.microsoft.com/office/drawing/2010/main">
-                <a:solidFill>
-                  <a:srgbClr val="FFFFFF"/>
-                </a:solidFill>
-              </a14:hiddenFill>
-            </a:ext>
-          </a:extLst>
-        </p:spPr>
-      </p:pic>
-      <p:pic>
-        <p:nvPicPr>
           <p:cNvPr id="9" name="Picture 8">
             <a:extLst>
               <a:ext uri="{FF2B5EF4-FFF2-40B4-BE49-F238E27FC236}">
@@ -30360,7 +30064,7 @@
           <p:nvPr/>
         </p:nvPicPr>
         <p:blipFill>
-          <a:blip r:embed="rId5"/>
+          <a:blip r:embed="rId4"/>
           <a:stretch>
             <a:fillRect/>
           </a:stretch>
@@ -30390,7 +30094,7 @@
           <p:nvPr/>
         </p:nvPicPr>
         <p:blipFill>
-          <a:blip r:embed="rId6"/>
+          <a:blip r:embed="rId5"/>
           <a:srcRect b="61544"/>
           <a:stretch/>
         </p:blipFill>
@@ -30519,7 +30223,7 @@
           <a:p>
             <a:fld id="{A16816AC-2982-C44D-A3E6-FA686AA382A6}" type="datetime1">
               <a:rPr lang="en-GB" noProof="1" smtClean="0"/>
-              <a:t>08/03/2025</a:t>
+              <a:t>01/03/2026</a:t>
             </a:fld>
             <a:endParaRPr lang="en-GB" noProof="1"/>
           </a:p>

</xml_diff>